<commit_message>
added comments in ppt
</commit_message>
<xml_diff>
--- a/_dev/Feedback/Consultant/23-Oct/10_23_2026_Update_For_Digital_Simulation.pptx
+++ b/_dev/Feedback/Consultant/23-Oct/10_23_2026_Update_For_Digital_Simulation.pptx
@@ -338,7 +338,7 @@
           <a:p>
             <a:fld id="{4C870BA3-8C99-4885-9116-D5C1F7B5A430}" type="datetimeFigureOut">
               <a:rPr lang="en-US" smtClean="0"/>
-              <a:t>10/24/2026</a:t>
+              <a:t>10/26/2026</a:t>
             </a:fld>
             <a:endParaRPr lang="en-US"/>
           </a:p>
@@ -16299,7 +16299,7 @@
           <a:p>
             <a:fld id="{5BCAD085-E8A6-8845-BD4E-CB4CCA059FC4}" type="datetimeFigureOut">
               <a:rPr lang="en-US" smtClean="0"/>
-              <a:t>10/24/2026</a:t>
+              <a:t>10/26/2026</a:t>
             </a:fld>
             <a:endParaRPr lang="en-US"/>
           </a:p>
@@ -37359,6 +37359,48 @@
           </a:p>
         </p:txBody>
       </p:sp>
+      <p:sp>
+        <p:nvSpPr>
+          <p:cNvPr id="3" name="TextBox 2">
+            <a:extLst>
+              <a:ext uri="{FF2B5EF4-FFF2-40B4-BE49-F238E27FC236}">
+                <a16:creationId xmlns:a16="http://schemas.microsoft.com/office/drawing/2014/main" id="{A0DB676A-5654-D590-BAC6-9947D5F71794}"/>
+              </a:ext>
+            </a:extLst>
+          </p:cNvPr>
+          <p:cNvSpPr txBox="1"/>
+          <p:nvPr/>
+        </p:nvSpPr>
+        <p:spPr>
+          <a:xfrm>
+            <a:off x="8104095" y="331694"/>
+            <a:ext cx="2931458" cy="276999"/>
+          </a:xfrm>
+          <a:prstGeom prst="rect">
+            <a:avLst/>
+          </a:prstGeom>
+          <a:solidFill>
+            <a:srgbClr val="92D050"/>
+          </a:solidFill>
+          <a:ln>
+            <a:noFill/>
+          </a:ln>
+        </p:spPr>
+        <p:txBody>
+          <a:bodyPr wrap="square" lIns="0" tIns="0" rIns="0" bIns="0" rtlCol="0">
+            <a:spAutoFit/>
+          </a:bodyPr>
+          <a:lstStyle/>
+          <a:p>
+            <a:pPr algn="l"/>
+            <a:r>
+              <a:rPr lang="en-US" dirty="0"/>
+              <a:t>Digital 26 Oct 2026 - Done</a:t>
+            </a:r>
+            <a:endParaRPr lang="en-IN" dirty="0"/>
+          </a:p>
+        </p:txBody>
+      </p:sp>
     </p:spTree>
     <p:extLst>
       <p:ext uri="{BB962C8B-B14F-4D97-AF65-F5344CB8AC3E}">
@@ -37649,6 +37691,48 @@
           </a:p>
         </p:txBody>
       </p:sp>
+      <p:sp>
+        <p:nvSpPr>
+          <p:cNvPr id="5" name="TextBox 4">
+            <a:extLst>
+              <a:ext uri="{FF2B5EF4-FFF2-40B4-BE49-F238E27FC236}">
+                <a16:creationId xmlns:a16="http://schemas.microsoft.com/office/drawing/2014/main" id="{3E9E936C-BDA4-F5BA-482F-2C924A0BE949}"/>
+              </a:ext>
+            </a:extLst>
+          </p:cNvPr>
+          <p:cNvSpPr txBox="1"/>
+          <p:nvPr/>
+        </p:nvSpPr>
+        <p:spPr>
+          <a:xfrm>
+            <a:off x="8104095" y="331694"/>
+            <a:ext cx="2931458" cy="276999"/>
+          </a:xfrm>
+          <a:prstGeom prst="rect">
+            <a:avLst/>
+          </a:prstGeom>
+          <a:solidFill>
+            <a:srgbClr val="92D050"/>
+          </a:solidFill>
+          <a:ln>
+            <a:noFill/>
+          </a:ln>
+        </p:spPr>
+        <p:txBody>
+          <a:bodyPr wrap="square" lIns="0" tIns="0" rIns="0" bIns="0" rtlCol="0">
+            <a:spAutoFit/>
+          </a:bodyPr>
+          <a:lstStyle/>
+          <a:p>
+            <a:pPr algn="l"/>
+            <a:r>
+              <a:rPr lang="en-US" dirty="0"/>
+              <a:t>Digital 26 Oct 2026 - Done</a:t>
+            </a:r>
+            <a:endParaRPr lang="en-IN" dirty="0"/>
+          </a:p>
+        </p:txBody>
+      </p:sp>
     </p:spTree>
     <p:extLst>
       <p:ext uri="{BB962C8B-B14F-4D97-AF65-F5344CB8AC3E}">
@@ -37834,6 +37918,48 @@
               <a:rPr lang="en-US"/>
               <a:t>Source doc Moment 1</a:t>
             </a:r>
+          </a:p>
+        </p:txBody>
+      </p:sp>
+      <p:sp>
+        <p:nvSpPr>
+          <p:cNvPr id="5" name="TextBox 4">
+            <a:extLst>
+              <a:ext uri="{FF2B5EF4-FFF2-40B4-BE49-F238E27FC236}">
+                <a16:creationId xmlns:a16="http://schemas.microsoft.com/office/drawing/2014/main" id="{5122FA99-8773-F37D-36E1-D709C6F08AF7}"/>
+              </a:ext>
+            </a:extLst>
+          </p:cNvPr>
+          <p:cNvSpPr txBox="1"/>
+          <p:nvPr/>
+        </p:nvSpPr>
+        <p:spPr>
+          <a:xfrm>
+            <a:off x="8104095" y="331694"/>
+            <a:ext cx="2931458" cy="276999"/>
+          </a:xfrm>
+          <a:prstGeom prst="rect">
+            <a:avLst/>
+          </a:prstGeom>
+          <a:solidFill>
+            <a:srgbClr val="92D050"/>
+          </a:solidFill>
+          <a:ln>
+            <a:noFill/>
+          </a:ln>
+        </p:spPr>
+        <p:txBody>
+          <a:bodyPr wrap="square" lIns="0" tIns="0" rIns="0" bIns="0" rtlCol="0">
+            <a:spAutoFit/>
+          </a:bodyPr>
+          <a:lstStyle/>
+          <a:p>
+            <a:pPr algn="l"/>
+            <a:r>
+              <a:rPr lang="en-US" dirty="0"/>
+              <a:t>Digital 26 Oct 2026 - Done</a:t>
+            </a:r>
+            <a:endParaRPr lang="en-IN" dirty="0"/>
           </a:p>
         </p:txBody>
       </p:sp>
@@ -38082,6 +38208,48 @@
           </a:p>
         </p:txBody>
       </p:sp>
+      <p:sp>
+        <p:nvSpPr>
+          <p:cNvPr id="5" name="TextBox 4">
+            <a:extLst>
+              <a:ext uri="{FF2B5EF4-FFF2-40B4-BE49-F238E27FC236}">
+                <a16:creationId xmlns:a16="http://schemas.microsoft.com/office/drawing/2014/main" id="{D40CC4C9-24F8-06EA-341B-A7E6318D9EA6}"/>
+              </a:ext>
+            </a:extLst>
+          </p:cNvPr>
+          <p:cNvSpPr txBox="1"/>
+          <p:nvPr/>
+        </p:nvSpPr>
+        <p:spPr>
+          <a:xfrm>
+            <a:off x="8104095" y="331694"/>
+            <a:ext cx="2931458" cy="276999"/>
+          </a:xfrm>
+          <a:prstGeom prst="rect">
+            <a:avLst/>
+          </a:prstGeom>
+          <a:solidFill>
+            <a:srgbClr val="92D050"/>
+          </a:solidFill>
+          <a:ln>
+            <a:noFill/>
+          </a:ln>
+        </p:spPr>
+        <p:txBody>
+          <a:bodyPr wrap="square" lIns="0" tIns="0" rIns="0" bIns="0" rtlCol="0">
+            <a:spAutoFit/>
+          </a:bodyPr>
+          <a:lstStyle/>
+          <a:p>
+            <a:pPr algn="l"/>
+            <a:r>
+              <a:rPr lang="en-US" dirty="0"/>
+              <a:t>Digital 26 Oct 2026 - Done</a:t>
+            </a:r>
+            <a:endParaRPr lang="en-IN" dirty="0"/>
+          </a:p>
+        </p:txBody>
+      </p:sp>
     </p:spTree>
     <p:extLst>
       <p:ext uri="{BB962C8B-B14F-4D97-AF65-F5344CB8AC3E}">
@@ -38313,6 +38481,48 @@
           </a:p>
         </p:txBody>
       </p:sp>
+      <p:sp>
+        <p:nvSpPr>
+          <p:cNvPr id="5" name="TextBox 4">
+            <a:extLst>
+              <a:ext uri="{FF2B5EF4-FFF2-40B4-BE49-F238E27FC236}">
+                <a16:creationId xmlns:a16="http://schemas.microsoft.com/office/drawing/2014/main" id="{CF0C9416-913C-BB13-2A6B-1FFF5904ECDB}"/>
+              </a:ext>
+            </a:extLst>
+          </p:cNvPr>
+          <p:cNvSpPr txBox="1"/>
+          <p:nvPr/>
+        </p:nvSpPr>
+        <p:spPr>
+          <a:xfrm>
+            <a:off x="8104095" y="331694"/>
+            <a:ext cx="2931458" cy="276999"/>
+          </a:xfrm>
+          <a:prstGeom prst="rect">
+            <a:avLst/>
+          </a:prstGeom>
+          <a:solidFill>
+            <a:srgbClr val="92D050"/>
+          </a:solidFill>
+          <a:ln>
+            <a:noFill/>
+          </a:ln>
+        </p:spPr>
+        <p:txBody>
+          <a:bodyPr wrap="square" lIns="0" tIns="0" rIns="0" bIns="0" rtlCol="0">
+            <a:spAutoFit/>
+          </a:bodyPr>
+          <a:lstStyle/>
+          <a:p>
+            <a:pPr algn="l"/>
+            <a:r>
+              <a:rPr lang="en-US" dirty="0"/>
+              <a:t>Digital 26 Oct 2026 - Done</a:t>
+            </a:r>
+            <a:endParaRPr lang="en-IN" dirty="0"/>
+          </a:p>
+        </p:txBody>
+      </p:sp>
     </p:spTree>
     <p:extLst>
       <p:ext uri="{BB962C8B-B14F-4D97-AF65-F5344CB8AC3E}">
@@ -38538,6 +38748,48 @@
           </a:p>
         </p:txBody>
       </p:sp>
+      <p:sp>
+        <p:nvSpPr>
+          <p:cNvPr id="5" name="TextBox 4">
+            <a:extLst>
+              <a:ext uri="{FF2B5EF4-FFF2-40B4-BE49-F238E27FC236}">
+                <a16:creationId xmlns:a16="http://schemas.microsoft.com/office/drawing/2014/main" id="{97B6E7A5-5B6C-55E8-7381-15F02D56FF06}"/>
+              </a:ext>
+            </a:extLst>
+          </p:cNvPr>
+          <p:cNvSpPr txBox="1"/>
+          <p:nvPr/>
+        </p:nvSpPr>
+        <p:spPr>
+          <a:xfrm>
+            <a:off x="8104095" y="331694"/>
+            <a:ext cx="2931458" cy="276999"/>
+          </a:xfrm>
+          <a:prstGeom prst="rect">
+            <a:avLst/>
+          </a:prstGeom>
+          <a:solidFill>
+            <a:srgbClr val="92D050"/>
+          </a:solidFill>
+          <a:ln>
+            <a:noFill/>
+          </a:ln>
+        </p:spPr>
+        <p:txBody>
+          <a:bodyPr wrap="square" lIns="0" tIns="0" rIns="0" bIns="0" rtlCol="0">
+            <a:spAutoFit/>
+          </a:bodyPr>
+          <a:lstStyle/>
+          <a:p>
+            <a:pPr algn="l"/>
+            <a:r>
+              <a:rPr lang="en-US" dirty="0"/>
+              <a:t>Digital 26 Oct 2026 - Done</a:t>
+            </a:r>
+            <a:endParaRPr lang="en-IN" dirty="0"/>
+          </a:p>
+        </p:txBody>
+      </p:sp>
     </p:spTree>
     <p:extLst>
       <p:ext uri="{BB962C8B-B14F-4D97-AF65-F5344CB8AC3E}">
@@ -38612,6 +38864,92 @@
           </a:p>
         </p:txBody>
       </p:sp>
+      <p:sp>
+        <p:nvSpPr>
+          <p:cNvPr id="2" name="TextBox 1">
+            <a:extLst>
+              <a:ext uri="{FF2B5EF4-FFF2-40B4-BE49-F238E27FC236}">
+                <a16:creationId xmlns:a16="http://schemas.microsoft.com/office/drawing/2014/main" id="{019F5FC0-3A77-DB18-BB7D-F41D24838BD8}"/>
+              </a:ext>
+            </a:extLst>
+          </p:cNvPr>
+          <p:cNvSpPr txBox="1"/>
+          <p:nvPr/>
+        </p:nvSpPr>
+        <p:spPr>
+          <a:xfrm>
+            <a:off x="6257364" y="1595718"/>
+            <a:ext cx="4715435" cy="1661993"/>
+          </a:xfrm>
+          <a:prstGeom prst="rect">
+            <a:avLst/>
+          </a:prstGeom>
+          <a:solidFill>
+            <a:srgbClr val="FFFF00"/>
+          </a:solidFill>
+          <a:ln>
+            <a:noFill/>
+          </a:ln>
+        </p:spPr>
+        <p:txBody>
+          <a:bodyPr wrap="square" lIns="0" tIns="0" rIns="0" bIns="0" rtlCol="0">
+            <a:spAutoFit/>
+          </a:bodyPr>
+          <a:lstStyle/>
+          <a:p>
+            <a:r>
+              <a:rPr lang="en-IN" b="1" dirty="0"/>
+              <a:t>Digital – 26 Oct 2026:</a:t>
+            </a:r>
+            <a:r>
+              <a:rPr lang="en-IN" dirty="0"/>
+              <a:t> The user must click </a:t>
+            </a:r>
+            <a:r>
+              <a:rPr lang="en-IN" b="1" dirty="0"/>
+              <a:t>“End Conversation”</a:t>
+            </a:r>
+            <a:r>
+              <a:rPr lang="en-IN" dirty="0"/>
+              <a:t> to end the chat. If the user leaves without ending the conversation, the previous chat history will remain visible when they log in again.</a:t>
+            </a:r>
+            <a:br>
+              <a:rPr lang="en-IN" dirty="0"/>
+            </a:br>
+            <a:endParaRPr lang="en-IN" dirty="0"/>
+          </a:p>
+        </p:txBody>
+      </p:sp>
+      <p:pic>
+        <p:nvPicPr>
+          <p:cNvPr id="5" name="Picture 4">
+            <a:extLst>
+              <a:ext uri="{FF2B5EF4-FFF2-40B4-BE49-F238E27FC236}">
+                <a16:creationId xmlns:a16="http://schemas.microsoft.com/office/drawing/2014/main" id="{921449A0-D581-E3B7-666B-421D10658569}"/>
+              </a:ext>
+            </a:extLst>
+          </p:cNvPr>
+          <p:cNvPicPr>
+            <a:picLocks noChangeAspect="1"/>
+          </p:cNvPicPr>
+          <p:nvPr/>
+        </p:nvPicPr>
+        <p:blipFill>
+          <a:blip r:embed="rId2"/>
+          <a:stretch>
+            <a:fillRect/>
+          </a:stretch>
+        </p:blipFill>
+        <p:spPr>
+          <a:xfrm>
+            <a:off x="6096000" y="3292308"/>
+            <a:ext cx="5441576" cy="2531627"/>
+          </a:xfrm>
+          <a:prstGeom prst="rect">
+            <a:avLst/>
+          </a:prstGeom>
+        </p:spPr>
+      </p:pic>
     </p:spTree>
     <p:extLst>
       <p:ext uri="{BB962C8B-B14F-4D97-AF65-F5344CB8AC3E}">

</xml_diff>

<commit_message>
Updated status of review comments
</commit_message>
<xml_diff>
--- a/_dev/Feedback/Consultant/23-Oct/10_23_2026_Update_For_Digital_Simulation.pptx
+++ b/_dev/Feedback/Consultant/23-Oct/10_23_2026_Update_For_Digital_Simulation.pptx
@@ -37373,8 +37373,8 @@
         </p:nvSpPr>
         <p:spPr>
           <a:xfrm>
-            <a:off x="8104095" y="331694"/>
-            <a:ext cx="2931458" cy="276999"/>
+            <a:off x="7265894" y="295303"/>
+            <a:ext cx="3336791" cy="276999"/>
           </a:xfrm>
           <a:prstGeom prst="rect">
             <a:avLst/>
@@ -37394,8 +37394,12 @@
           <a:p>
             <a:pPr algn="l"/>
             <a:r>
+              <a:rPr lang="en-US" b="1" dirty="0"/>
+              <a:t>Digital (26-Oct):</a:t>
+            </a:r>
+            <a:r>
               <a:rPr lang="en-US" dirty="0"/>
-              <a:t>Digital 26 Oct 2026 - Done</a:t>
+              <a:t> Done</a:t>
             </a:r>
             <a:endParaRPr lang="en-IN" dirty="0"/>
           </a:p>
@@ -37679,7 +37683,12 @@
             <p:ph type="title"/>
           </p:nvPr>
         </p:nvSpPr>
-        <p:spPr/>
+        <p:spPr>
+          <a:xfrm>
+            <a:off x="381000" y="381001"/>
+            <a:ext cx="4288971" cy="500742"/>
+          </a:xfrm>
+        </p:spPr>
         <p:txBody>
           <a:bodyPr/>
           <a:lstStyle/>
@@ -37693,10 +37702,10 @@
       </p:sp>
       <p:sp>
         <p:nvSpPr>
-          <p:cNvPr id="5" name="TextBox 4">
+          <p:cNvPr id="6" name="TextBox 5">
             <a:extLst>
               <a:ext uri="{FF2B5EF4-FFF2-40B4-BE49-F238E27FC236}">
-                <a16:creationId xmlns:a16="http://schemas.microsoft.com/office/drawing/2014/main" id="{3E9E936C-BDA4-F5BA-482F-2C924A0BE949}"/>
+                <a16:creationId xmlns:a16="http://schemas.microsoft.com/office/drawing/2014/main" id="{276DA494-25C1-9572-E30E-A2A034DF0F56}"/>
               </a:ext>
             </a:extLst>
           </p:cNvPr>
@@ -37705,8 +37714,8 @@
         </p:nvSpPr>
         <p:spPr>
           <a:xfrm>
-            <a:off x="8104095" y="331694"/>
-            <a:ext cx="2931458" cy="276999"/>
+            <a:off x="5660571" y="295303"/>
+            <a:ext cx="5442857" cy="830997"/>
           </a:xfrm>
           <a:prstGeom prst="rect">
             <a:avLst/>
@@ -37726,8 +37735,19 @@
           <a:p>
             <a:pPr algn="l"/>
             <a:r>
+              <a:rPr lang="en-US" b="1" dirty="0"/>
+              <a:t>Digital (26-Oct):</a:t>
+            </a:r>
+            <a:r>
               <a:rPr lang="en-US" dirty="0"/>
-              <a:t>Digital 26 Oct 2026 - Done</a:t>
+              <a:t> Done</a:t>
+            </a:r>
+          </a:p>
+          <a:p>
+            <a:pPr algn="l"/>
+            <a:r>
+              <a:rPr lang="en-US" dirty="0"/>
+              <a:t>Basis the feedback on 19-Oct, we have NOT added Moment’s title in the sim.</a:t>
             </a:r>
             <a:endParaRPr lang="en-IN" dirty="0"/>
           </a:p>
@@ -37923,10 +37943,10 @@
       </p:sp>
       <p:sp>
         <p:nvSpPr>
-          <p:cNvPr id="5" name="TextBox 4">
+          <p:cNvPr id="6" name="TextBox 5">
             <a:extLst>
               <a:ext uri="{FF2B5EF4-FFF2-40B4-BE49-F238E27FC236}">
-                <a16:creationId xmlns:a16="http://schemas.microsoft.com/office/drawing/2014/main" id="{5122FA99-8773-F37D-36E1-D709C6F08AF7}"/>
+                <a16:creationId xmlns:a16="http://schemas.microsoft.com/office/drawing/2014/main" id="{7F78F3ED-B561-1508-AC74-ED77DC6D50B3}"/>
               </a:ext>
             </a:extLst>
           </p:cNvPr>
@@ -37935,8 +37955,8 @@
         </p:nvSpPr>
         <p:spPr>
           <a:xfrm>
-            <a:off x="8104095" y="331694"/>
-            <a:ext cx="2931458" cy="276999"/>
+            <a:off x="7265894" y="295303"/>
+            <a:ext cx="3336791" cy="276999"/>
           </a:xfrm>
           <a:prstGeom prst="rect">
             <a:avLst/>
@@ -37956,8 +37976,12 @@
           <a:p>
             <a:pPr algn="l"/>
             <a:r>
+              <a:rPr lang="en-US" b="1" dirty="0"/>
+              <a:t>Digital (26-Oct):</a:t>
+            </a:r>
+            <a:r>
               <a:rPr lang="en-US" dirty="0"/>
-              <a:t>Digital 26 Oct 2026 - Done</a:t>
+              <a:t> Done</a:t>
             </a:r>
             <a:endParaRPr lang="en-IN" dirty="0"/>
           </a:p>
@@ -38210,10 +38234,10 @@
       </p:sp>
       <p:sp>
         <p:nvSpPr>
-          <p:cNvPr id="5" name="TextBox 4">
+          <p:cNvPr id="6" name="TextBox 5">
             <a:extLst>
               <a:ext uri="{FF2B5EF4-FFF2-40B4-BE49-F238E27FC236}">
-                <a16:creationId xmlns:a16="http://schemas.microsoft.com/office/drawing/2014/main" id="{D40CC4C9-24F8-06EA-341B-A7E6318D9EA6}"/>
+                <a16:creationId xmlns:a16="http://schemas.microsoft.com/office/drawing/2014/main" id="{49301015-5973-0BE7-E038-24AD1DB84943}"/>
               </a:ext>
             </a:extLst>
           </p:cNvPr>
@@ -38222,8 +38246,8 @@
         </p:nvSpPr>
         <p:spPr>
           <a:xfrm>
-            <a:off x="8104095" y="331694"/>
-            <a:ext cx="2931458" cy="276999"/>
+            <a:off x="5660571" y="295303"/>
+            <a:ext cx="5442857" cy="830997"/>
           </a:xfrm>
           <a:prstGeom prst="rect">
             <a:avLst/>
@@ -38243,8 +38267,19 @@
           <a:p>
             <a:pPr algn="l"/>
             <a:r>
+              <a:rPr lang="en-US" b="1" dirty="0"/>
+              <a:t>Digital (26-Oct):</a:t>
+            </a:r>
+            <a:r>
               <a:rPr lang="en-US" dirty="0"/>
-              <a:t>Digital 26 Oct 2026 - Done</a:t>
+              <a:t> Done</a:t>
+            </a:r>
+          </a:p>
+          <a:p>
+            <a:pPr algn="l"/>
+            <a:r>
+              <a:rPr lang="en-US" dirty="0"/>
+              <a:t>Basis the feedback on 19-Oct, we have NOT added Moment’s title in the sim.</a:t>
             </a:r>
             <a:endParaRPr lang="en-IN" dirty="0"/>
           </a:p>
@@ -38483,10 +38518,10 @@
       </p:sp>
       <p:sp>
         <p:nvSpPr>
-          <p:cNvPr id="5" name="TextBox 4">
+          <p:cNvPr id="6" name="TextBox 5">
             <a:extLst>
               <a:ext uri="{FF2B5EF4-FFF2-40B4-BE49-F238E27FC236}">
-                <a16:creationId xmlns:a16="http://schemas.microsoft.com/office/drawing/2014/main" id="{CF0C9416-913C-BB13-2A6B-1FFF5904ECDB}"/>
+                <a16:creationId xmlns:a16="http://schemas.microsoft.com/office/drawing/2014/main" id="{ABD2A9E2-E3B5-0DDE-D1F6-345BDA91CEF3}"/>
               </a:ext>
             </a:extLst>
           </p:cNvPr>
@@ -38495,8 +38530,8 @@
         </p:nvSpPr>
         <p:spPr>
           <a:xfrm>
-            <a:off x="8104095" y="331694"/>
-            <a:ext cx="2931458" cy="276999"/>
+            <a:off x="5660572" y="295303"/>
+            <a:ext cx="2764972" cy="276999"/>
           </a:xfrm>
           <a:prstGeom prst="rect">
             <a:avLst/>
@@ -38516,10 +38551,13 @@
           <a:p>
             <a:pPr algn="l"/>
             <a:r>
+              <a:rPr lang="en-US" b="1" dirty="0"/>
+              <a:t>Digital (26-Oct):</a:t>
+            </a:r>
+            <a:r>
               <a:rPr lang="en-US" dirty="0"/>
-              <a:t>Digital 26 Oct 2026 - Done</a:t>
+              <a:t> Done</a:t>
             </a:r>
-            <a:endParaRPr lang="en-IN" dirty="0"/>
           </a:p>
         </p:txBody>
       </p:sp>
@@ -38750,10 +38788,10 @@
       </p:sp>
       <p:sp>
         <p:nvSpPr>
-          <p:cNvPr id="5" name="TextBox 4">
+          <p:cNvPr id="6" name="TextBox 5">
             <a:extLst>
               <a:ext uri="{FF2B5EF4-FFF2-40B4-BE49-F238E27FC236}">
-                <a16:creationId xmlns:a16="http://schemas.microsoft.com/office/drawing/2014/main" id="{97B6E7A5-5B6C-55E8-7381-15F02D56FF06}"/>
+                <a16:creationId xmlns:a16="http://schemas.microsoft.com/office/drawing/2014/main" id="{EF42FCFB-081B-AFEA-70FF-326152D64218}"/>
               </a:ext>
             </a:extLst>
           </p:cNvPr>
@@ -38762,8 +38800,8 @@
         </p:nvSpPr>
         <p:spPr>
           <a:xfrm>
-            <a:off x="8104095" y="331694"/>
-            <a:ext cx="2931458" cy="276999"/>
+            <a:off x="5660571" y="295303"/>
+            <a:ext cx="5442857" cy="830997"/>
           </a:xfrm>
           <a:prstGeom prst="rect">
             <a:avLst/>
@@ -38783,8 +38821,19 @@
           <a:p>
             <a:pPr algn="l"/>
             <a:r>
+              <a:rPr lang="en-US" b="1" dirty="0"/>
+              <a:t>Digital (26-Oct):</a:t>
+            </a:r>
+            <a:r>
               <a:rPr lang="en-US" dirty="0"/>
-              <a:t>Digital 26 Oct 2026 - Done</a:t>
+              <a:t> Done</a:t>
+            </a:r>
+          </a:p>
+          <a:p>
+            <a:pPr algn="l"/>
+            <a:r>
+              <a:rPr lang="en-US" dirty="0"/>
+              <a:t>Basis the feedback on 19-Oct, we have NOT added Moment’s title in the sim.</a:t>
             </a:r>
             <a:endParaRPr lang="en-IN" dirty="0"/>
           </a:p>
@@ -38878,14 +38927,14 @@
         </p:nvSpPr>
         <p:spPr>
           <a:xfrm>
-            <a:off x="6257364" y="1595718"/>
-            <a:ext cx="4715435" cy="1661993"/>
+            <a:off x="654424" y="1630315"/>
+            <a:ext cx="9828519" cy="1384995"/>
           </a:xfrm>
           <a:prstGeom prst="rect">
             <a:avLst/>
           </a:prstGeom>
           <a:solidFill>
-            <a:srgbClr val="FFFF00"/>
+            <a:srgbClr val="FFC000"/>
           </a:solidFill>
           <a:ln>
             <a:noFill/>
@@ -38899,11 +38948,17 @@
           <a:p>
             <a:r>
               <a:rPr lang="en-IN" b="1" dirty="0"/>
-              <a:t>Digital – 26 Oct 2026:</a:t>
+              <a:t>Digital (26-Oct): </a:t>
             </a:r>
             <a:r>
               <a:rPr lang="en-IN" dirty="0"/>
-              <a:t> The user must click </a:t>
+              <a:t>Could not replicate the issue.</a:t>
+            </a:r>
+          </a:p>
+          <a:p>
+            <a:r>
+              <a:rPr lang="en-IN" dirty="0"/>
+              <a:t>Please note that users must click </a:t>
             </a:r>
             <a:r>
               <a:rPr lang="en-IN" b="1" dirty="0"/>
@@ -38911,12 +38966,14 @@
             </a:r>
             <a:r>
               <a:rPr lang="en-IN" dirty="0"/>
-              <a:t> to end the chat. If the user leaves without ending the conversation, the previous chat history will remain visible when they log in again.</a:t>
+              <a:t> to end the chat. This is also the only way for them to receive the report.</a:t>
             </a:r>
-            <a:br>
-              <a:rPr lang="en-IN" dirty="0"/>
-            </a:br>
-            <a:endParaRPr lang="en-IN" dirty="0"/>
+          </a:p>
+          <a:p>
+            <a:r>
+              <a:rPr lang="en-IN"/>
+              <a:t>If a user leaves without ending the conversation, their previous chat history will remain visible when they log in again.</a:t>
+            </a:r>
           </a:p>
         </p:txBody>
       </p:sp>

</xml_diff>